<commit_message>
Guard reviewer reminder incident hold
</commit_message>
<xml_diff>
--- a/docs/onboarding/Workbench_Onboarding_PD.pptx
+++ b/docs/onboarding/Workbench_Onboarding_PD.pptx
@@ -2,45 +2,45 @@
 <file path=ppt/presentation.xml><?xml version="1.0" encoding="utf-8"?>
 <p:presentation xmlns:p="http://schemas.openxmlformats.org/presentationml/2006/main">
   <p:sldMasterIdLst>
-    <p:sldMasterId xmlns:r="http://schemas.openxmlformats.org/officeDocument/2006/relationships" id="2147483648" r:id="R7703b73d0a074dc0"/>
+    <p:sldMasterId xmlns:r="http://schemas.openxmlformats.org/officeDocument/2006/relationships" id="2147483648" r:id="Rd3e677f4e00d4f92"/>
   </p:sldMasterIdLst>
   <p:notesMasterIdLst>
-    <p:notesMasterId xmlns:r="http://schemas.openxmlformats.org/officeDocument/2006/relationships" r:id="R4f74ae8b533b496f"/>
+    <p:notesMasterId xmlns:r="http://schemas.openxmlformats.org/officeDocument/2006/relationships" r:id="R126cc571274d4565"/>
   </p:notesMasterIdLst>
   <p:sldIdLst>
-    <p:sldId xmlns:r="http://schemas.openxmlformats.org/officeDocument/2006/relationships" id="256" r:id="R57c6b41675a64590"/>
-    <p:sldId xmlns:r="http://schemas.openxmlformats.org/officeDocument/2006/relationships" id="257" r:id="Rba1267fd3ed44260"/>
-    <p:sldId xmlns:r="http://schemas.openxmlformats.org/officeDocument/2006/relationships" id="258" r:id="R2035425ee5fc4684"/>
-    <p:sldId xmlns:r="http://schemas.openxmlformats.org/officeDocument/2006/relationships" id="259" r:id="Ra47146802ad14661"/>
-    <p:sldId xmlns:r="http://schemas.openxmlformats.org/officeDocument/2006/relationships" id="260" r:id="Re159f37f010c4fb1"/>
-    <p:sldId xmlns:r="http://schemas.openxmlformats.org/officeDocument/2006/relationships" id="261" r:id="R2d48de41fc5647e4"/>
-    <p:sldId xmlns:r="http://schemas.openxmlformats.org/officeDocument/2006/relationships" id="262" r:id="R09111897a334483a"/>
-    <p:sldId xmlns:r="http://schemas.openxmlformats.org/officeDocument/2006/relationships" id="263" r:id="Re698c6bcebc44d1e"/>
-    <p:sldId xmlns:r="http://schemas.openxmlformats.org/officeDocument/2006/relationships" id="264" r:id="R00b25e70c1474308"/>
-    <p:sldId xmlns:r="http://schemas.openxmlformats.org/officeDocument/2006/relationships" id="265" r:id="R34ffe551e0ab4461"/>
-    <p:sldId xmlns:r="http://schemas.openxmlformats.org/officeDocument/2006/relationships" id="266" r:id="Re365a5e23fea492a"/>
-    <p:sldId xmlns:r="http://schemas.openxmlformats.org/officeDocument/2006/relationships" id="267" r:id="Rc6f78c90f00d4b41"/>
-    <p:sldId xmlns:r="http://schemas.openxmlformats.org/officeDocument/2006/relationships" id="268" r:id="Redd76a5b7a9a4fc2"/>
-    <p:sldId xmlns:r="http://schemas.openxmlformats.org/officeDocument/2006/relationships" id="269" r:id="R5802f1019e97455f"/>
-    <p:sldId xmlns:r="http://schemas.openxmlformats.org/officeDocument/2006/relationships" id="270" r:id="Rb2378701ed814e9e"/>
-    <p:sldId xmlns:r="http://schemas.openxmlformats.org/officeDocument/2006/relationships" id="271" r:id="R6725b680ca0044ba"/>
-    <p:sldId xmlns:r="http://schemas.openxmlformats.org/officeDocument/2006/relationships" id="272" r:id="Rc7595f34a3ef45f4"/>
-    <p:sldId xmlns:r="http://schemas.openxmlformats.org/officeDocument/2006/relationships" id="273" r:id="R01b88814f16147bb"/>
-    <p:sldId xmlns:r="http://schemas.openxmlformats.org/officeDocument/2006/relationships" id="274" r:id="R2107efada5114c74"/>
-    <p:sldId xmlns:r="http://schemas.openxmlformats.org/officeDocument/2006/relationships" id="275" r:id="Rac2879fbb06c47f4"/>
-    <p:sldId xmlns:r="http://schemas.openxmlformats.org/officeDocument/2006/relationships" id="276" r:id="Rbee3fd20663e4f5a"/>
-    <p:sldId xmlns:r="http://schemas.openxmlformats.org/officeDocument/2006/relationships" id="277" r:id="Rf0b4f71ed0854114"/>
-    <p:sldId xmlns:r="http://schemas.openxmlformats.org/officeDocument/2006/relationships" id="278" r:id="R98a3059f4f4041f8"/>
-    <p:sldId xmlns:r="http://schemas.openxmlformats.org/officeDocument/2006/relationships" id="279" r:id="R7089e70aeeb04b96"/>
-    <p:sldId xmlns:r="http://schemas.openxmlformats.org/officeDocument/2006/relationships" id="280" r:id="Rf9a9e9ef78de4fda"/>
-    <p:sldId xmlns:r="http://schemas.openxmlformats.org/officeDocument/2006/relationships" id="281" r:id="R994c3cd6d7014c93"/>
-    <p:sldId xmlns:r="http://schemas.openxmlformats.org/officeDocument/2006/relationships" id="282" r:id="R87f98428c66d4550"/>
-    <p:sldId xmlns:r="http://schemas.openxmlformats.org/officeDocument/2006/relationships" id="283" r:id="R59d78646eb63493f"/>
-    <p:sldId xmlns:r="http://schemas.openxmlformats.org/officeDocument/2006/relationships" id="284" r:id="R22273925258f4cc2"/>
-    <p:sldId xmlns:r="http://schemas.openxmlformats.org/officeDocument/2006/relationships" id="285" r:id="Rb5ae07889ef54ae4"/>
-    <p:sldId xmlns:r="http://schemas.openxmlformats.org/officeDocument/2006/relationships" id="286" r:id="Red8d2941950742d0"/>
-    <p:sldId xmlns:r="http://schemas.openxmlformats.org/officeDocument/2006/relationships" id="287" r:id="R4ab9fd8a343e4aef"/>
-    <p:sldId xmlns:r="http://schemas.openxmlformats.org/officeDocument/2006/relationships" id="288" r:id="Rde178659951b42fb"/>
+    <p:sldId xmlns:r="http://schemas.openxmlformats.org/officeDocument/2006/relationships" id="256" r:id="R835bab5646c14dff"/>
+    <p:sldId xmlns:r="http://schemas.openxmlformats.org/officeDocument/2006/relationships" id="257" r:id="R165a66ff53ac4f7b"/>
+    <p:sldId xmlns:r="http://schemas.openxmlformats.org/officeDocument/2006/relationships" id="258" r:id="R8ba2d5c0109b4daf"/>
+    <p:sldId xmlns:r="http://schemas.openxmlformats.org/officeDocument/2006/relationships" id="259" r:id="R70e83e133ffc4c30"/>
+    <p:sldId xmlns:r="http://schemas.openxmlformats.org/officeDocument/2006/relationships" id="260" r:id="Rd3020e28875d431e"/>
+    <p:sldId xmlns:r="http://schemas.openxmlformats.org/officeDocument/2006/relationships" id="261" r:id="R18067780c2364661"/>
+    <p:sldId xmlns:r="http://schemas.openxmlformats.org/officeDocument/2006/relationships" id="262" r:id="R5f628456694c480a"/>
+    <p:sldId xmlns:r="http://schemas.openxmlformats.org/officeDocument/2006/relationships" id="263" r:id="R67d37ec1489d48db"/>
+    <p:sldId xmlns:r="http://schemas.openxmlformats.org/officeDocument/2006/relationships" id="264" r:id="R5c336622b6544a0b"/>
+    <p:sldId xmlns:r="http://schemas.openxmlformats.org/officeDocument/2006/relationships" id="265" r:id="R8cf1bba0fc74439f"/>
+    <p:sldId xmlns:r="http://schemas.openxmlformats.org/officeDocument/2006/relationships" id="266" r:id="Ree008b4b620c402c"/>
+    <p:sldId xmlns:r="http://schemas.openxmlformats.org/officeDocument/2006/relationships" id="267" r:id="Rb1c85fa4509e442b"/>
+    <p:sldId xmlns:r="http://schemas.openxmlformats.org/officeDocument/2006/relationships" id="268" r:id="Ra3d18f33321840a7"/>
+    <p:sldId xmlns:r="http://schemas.openxmlformats.org/officeDocument/2006/relationships" id="269" r:id="R2e2ee1d34c0f48c2"/>
+    <p:sldId xmlns:r="http://schemas.openxmlformats.org/officeDocument/2006/relationships" id="270" r:id="R035edd74e8d246c4"/>
+    <p:sldId xmlns:r="http://schemas.openxmlformats.org/officeDocument/2006/relationships" id="271" r:id="R777f8acd138c4a91"/>
+    <p:sldId xmlns:r="http://schemas.openxmlformats.org/officeDocument/2006/relationships" id="272" r:id="R65bb276e2b8f4a21"/>
+    <p:sldId xmlns:r="http://schemas.openxmlformats.org/officeDocument/2006/relationships" id="273" r:id="R6dbe5ecf6d1f40ba"/>
+    <p:sldId xmlns:r="http://schemas.openxmlformats.org/officeDocument/2006/relationships" id="274" r:id="R6b0d8e9a31c143e4"/>
+    <p:sldId xmlns:r="http://schemas.openxmlformats.org/officeDocument/2006/relationships" id="275" r:id="R9c213ce763b547fa"/>
+    <p:sldId xmlns:r="http://schemas.openxmlformats.org/officeDocument/2006/relationships" id="276" r:id="R690a1ae29ad346c8"/>
+    <p:sldId xmlns:r="http://schemas.openxmlformats.org/officeDocument/2006/relationships" id="277" r:id="R0ac2fc3c94d844b1"/>
+    <p:sldId xmlns:r="http://schemas.openxmlformats.org/officeDocument/2006/relationships" id="278" r:id="Ra6456b520f974e9c"/>
+    <p:sldId xmlns:r="http://schemas.openxmlformats.org/officeDocument/2006/relationships" id="279" r:id="R7d384c6ecd8846ac"/>
+    <p:sldId xmlns:r="http://schemas.openxmlformats.org/officeDocument/2006/relationships" id="280" r:id="R45fa857d82774330"/>
+    <p:sldId xmlns:r="http://schemas.openxmlformats.org/officeDocument/2006/relationships" id="281" r:id="R8b497f9da3584f12"/>
+    <p:sldId xmlns:r="http://schemas.openxmlformats.org/officeDocument/2006/relationships" id="282" r:id="R0d5f380913f44c9c"/>
+    <p:sldId xmlns:r="http://schemas.openxmlformats.org/officeDocument/2006/relationships" id="283" r:id="R561435a67fb045cc"/>
+    <p:sldId xmlns:r="http://schemas.openxmlformats.org/officeDocument/2006/relationships" id="284" r:id="Ra3f07bf617764c22"/>
+    <p:sldId xmlns:r="http://schemas.openxmlformats.org/officeDocument/2006/relationships" id="285" r:id="Ra779bd9874b94272"/>
+    <p:sldId xmlns:r="http://schemas.openxmlformats.org/officeDocument/2006/relationships" id="286" r:id="R7006678c53194949"/>
+    <p:sldId xmlns:r="http://schemas.openxmlformats.org/officeDocument/2006/relationships" id="287" r:id="R35fe6831afb14476"/>
+    <p:sldId xmlns:r="http://schemas.openxmlformats.org/officeDocument/2006/relationships" id="288" r:id="R494c2ccfb6b84a07"/>
   </p:sldIdLst>
   <p:sldSz cx="12191695" cy="6858000"/>
   <p:notesSz cx="6858000" cy="9144000"/>
@@ -5561,17 +5561,17 @@
   </p:cSld>
   <p:clrMap bg1="lt1" tx1="dk1" bg2="lt2" tx2="dk2" accent1="accent1" accent2="accent2" accent3="accent3" accent4="accent4" accent5="accent5" accent6="accent6" hlink="hlink" folHlink="folHlink"/>
   <p:sldLayoutIdLst>
-    <p:sldLayoutId xmlns:r="http://schemas.openxmlformats.org/officeDocument/2006/relationships" id="2147483649" r:id="R4cda30115e6442b3"/>
-    <p:sldLayoutId xmlns:r="http://schemas.openxmlformats.org/officeDocument/2006/relationships" id="2147483650" r:id="Rfb306b12ea454cd1"/>
-    <p:sldLayoutId xmlns:r="http://schemas.openxmlformats.org/officeDocument/2006/relationships" id="2147483651" r:id="Re1efbe3e1c08430f"/>
-    <p:sldLayoutId xmlns:r="http://schemas.openxmlformats.org/officeDocument/2006/relationships" id="2147483652" r:id="R2fc4fff693f848d6"/>
-    <p:sldLayoutId xmlns:r="http://schemas.openxmlformats.org/officeDocument/2006/relationships" id="2147483653" r:id="Ra4510815dfd941a4"/>
-    <p:sldLayoutId xmlns:r="http://schemas.openxmlformats.org/officeDocument/2006/relationships" id="2147483654" r:id="Rc8cf0374310d4f8f"/>
-    <p:sldLayoutId xmlns:r="http://schemas.openxmlformats.org/officeDocument/2006/relationships" id="2147483655" r:id="Rebd7ca52d5c94792"/>
-    <p:sldLayoutId xmlns:r="http://schemas.openxmlformats.org/officeDocument/2006/relationships" id="2147483656" r:id="R2629f93aba814d9a"/>
-    <p:sldLayoutId xmlns:r="http://schemas.openxmlformats.org/officeDocument/2006/relationships" id="2147483657" r:id="Rf2752faf53494af9"/>
-    <p:sldLayoutId xmlns:r="http://schemas.openxmlformats.org/officeDocument/2006/relationships" id="2147483658" r:id="Rf4100736128a4102"/>
-    <p:sldLayoutId xmlns:r="http://schemas.openxmlformats.org/officeDocument/2006/relationships" id="2147483659" r:id="R53701b0df1854996"/>
+    <p:sldLayoutId xmlns:r="http://schemas.openxmlformats.org/officeDocument/2006/relationships" id="2147483649" r:id="R75af3084c91c4080"/>
+    <p:sldLayoutId xmlns:r="http://schemas.openxmlformats.org/officeDocument/2006/relationships" id="2147483650" r:id="R5404fd9e6da44931"/>
+    <p:sldLayoutId xmlns:r="http://schemas.openxmlformats.org/officeDocument/2006/relationships" id="2147483651" r:id="Rad6d61ea3f684b0e"/>
+    <p:sldLayoutId xmlns:r="http://schemas.openxmlformats.org/officeDocument/2006/relationships" id="2147483652" r:id="R4b1010e6979b4647"/>
+    <p:sldLayoutId xmlns:r="http://schemas.openxmlformats.org/officeDocument/2006/relationships" id="2147483653" r:id="R6af1e749d49649b3"/>
+    <p:sldLayoutId xmlns:r="http://schemas.openxmlformats.org/officeDocument/2006/relationships" id="2147483654" r:id="Rb2870ed3e3b4482a"/>
+    <p:sldLayoutId xmlns:r="http://schemas.openxmlformats.org/officeDocument/2006/relationships" id="2147483655" r:id="R20aadb18e1104c18"/>
+    <p:sldLayoutId xmlns:r="http://schemas.openxmlformats.org/officeDocument/2006/relationships" id="2147483656" r:id="Ra0cf298bcddb4611"/>
+    <p:sldLayoutId xmlns:r="http://schemas.openxmlformats.org/officeDocument/2006/relationships" id="2147483657" r:id="Rd7dd16b1ba9c4af3"/>
+    <p:sldLayoutId xmlns:r="http://schemas.openxmlformats.org/officeDocument/2006/relationships" id="2147483658" r:id="R2abea48a3b1e485a"/>
+    <p:sldLayoutId xmlns:r="http://schemas.openxmlformats.org/officeDocument/2006/relationships" id="2147483659" r:id="R3a428b6bcd4a44de"/>
   </p:sldLayoutIdLst>
   <p:txStyles>
     <p:titleStyle>
@@ -7799,7 +7799,7 @@
               </a:defRPr>
             </a:pPr>
             <a:r>
-              <a:t>Invited people who haven't replied are nudged automatically by a reminder (Step 8/11).</a:t>
+              <a:t>Automatic reminders are paused; do not use a link-bearing resend during the incident hold.</a:t>
             </a:r>
           </a:p>
         </p:txBody>
@@ -8220,7 +8220,7 @@
               </a:defRPr>
             </a:pPr>
             <a:r>
-              <a:t>Reminders — turn the respond-by and review-due nudges on/off and set how many days before.</a:t>
+              <a:t>Reminder controls are not available in this panel; automatic reminders are paused.</a:t>
             </a:r>
           </a:p>
           <a:p xmlns:a="http://schemas.openxmlformats.org/drawingml/2006/main">
@@ -9757,7 +9757,7 @@
               </a:defRPr>
             </a:pPr>
             <a:r>
-              <a:t>The system chases for you:</a:t>
+              <a:t>Automatic reviewer reminders are paused during the token-incident hold.</a:t>
             </a:r>
           </a:p>
           <a:p xmlns:a="http://schemas.openxmlformats.org/drawingml/2006/main">
@@ -9773,7 +9773,7 @@
               </a:defRPr>
             </a:pPr>
             <a:r>
-              <a:t>Respond-by reminder nudges invitees who haven't replied.</a:t>
+              <a:t>Manual token-issuing reminders and resends are also procedurally frozen.</a:t>
             </a:r>
           </a:p>
           <a:p xmlns:a="http://schemas.openxmlformats.org/drawingml/2006/main">
@@ -9789,7 +9789,7 @@
               </a:defRPr>
             </a:pPr>
             <a:r>
-              <a:t>Review-due reminder nudges accepted reviewers who haven't submitted.</a:t>
+              <a:t>Do not issue or regenerate reviewer links until the hold is lifted.</a:t>
             </a:r>
           </a:p>
         </p:txBody>
@@ -11782,7 +11782,7 @@
               </a:defRPr>
             </a:pPr>
             <a:r>
-              <a:t>"Where did the Re-invite button go?" — replaced by the automatic respond-by reminder.</a:t>
+              <a:t>"Where did the Re-invite button go?" — it was removed; automatic reminders are currently paused.</a:t>
             </a:r>
           </a:p>
           <a:p xmlns:a="http://schemas.openxmlformats.org/drawingml/2006/main">

</xml_diff>